<commit_message>
Feedback Marc final sprint4
</commit_message>
<xml_diff>
--- a/ENTREGA FINAL/4. Diagramas de secuencia/Marc Sala.pptx
+++ b/ENTREGA FINAL/4. Diagramas de secuencia/Marc Sala.pptx
@@ -6561,10 +6561,10 @@
       </p:sp>
       <p:pic>
         <p:nvPicPr>
-          <p:cNvPr id="3" name="Imagen 2">
-            <a:extLst>
-              <a:ext uri="{FF2B5EF4-FFF2-40B4-BE49-F238E27FC236}">
-                <a16:creationId xmlns:a16="http://schemas.microsoft.com/office/drawing/2014/main" id="{D26B1A8C-2479-2DB9-9DD8-73D905AB0AD9}"/>
+          <p:cNvPr id="5" name="Imagen 4">
+            <a:extLst>
+              <a:ext uri="{FF2B5EF4-FFF2-40B4-BE49-F238E27FC236}">
+                <a16:creationId xmlns:a16="http://schemas.microsoft.com/office/drawing/2014/main" id="{2A84785A-4A3D-DF1B-0CB2-A04A1F357984}"/>
               </a:ext>
             </a:extLst>
           </p:cNvPr>
@@ -6587,8 +6587,8 @@
         </p:blipFill>
         <p:spPr>
           <a:xfrm>
-            <a:off x="581025" y="223837"/>
-            <a:ext cx="11029950" cy="6410325"/>
+            <a:off x="1163515" y="0"/>
+            <a:ext cx="9864969" cy="6858000"/>
           </a:xfrm>
           <a:prstGeom prst="rect">
             <a:avLst/>
@@ -6822,10 +6822,10 @@
       </p:sp>
       <p:pic>
         <p:nvPicPr>
-          <p:cNvPr id="3" name="Imagen 2">
-            <a:extLst>
-              <a:ext uri="{FF2B5EF4-FFF2-40B4-BE49-F238E27FC236}">
-                <a16:creationId xmlns:a16="http://schemas.microsoft.com/office/drawing/2014/main" id="{E7D98387-8AA4-15E6-E936-871AB93C2F3D}"/>
+          <p:cNvPr id="5" name="Imagen 4">
+            <a:extLst>
+              <a:ext uri="{FF2B5EF4-FFF2-40B4-BE49-F238E27FC236}">
+                <a16:creationId xmlns:a16="http://schemas.microsoft.com/office/drawing/2014/main" id="{7034F93E-29F2-9ED8-D2FD-A5A7DC03424B}"/>
               </a:ext>
             </a:extLst>
           </p:cNvPr>
@@ -6848,8 +6848,8 @@
         </p:blipFill>
         <p:spPr>
           <a:xfrm>
-            <a:off x="161925" y="38100"/>
-            <a:ext cx="11868150" cy="6781800"/>
+            <a:off x="161925" y="247650"/>
+            <a:ext cx="11868150" cy="6362700"/>
           </a:xfrm>
           <a:prstGeom prst="rect">
             <a:avLst/>
@@ -7083,10 +7083,10 @@
       </p:sp>
       <p:pic>
         <p:nvPicPr>
-          <p:cNvPr id="3" name="Imagen 2">
-            <a:extLst>
-              <a:ext uri="{FF2B5EF4-FFF2-40B4-BE49-F238E27FC236}">
-                <a16:creationId xmlns:a16="http://schemas.microsoft.com/office/drawing/2014/main" id="{F3E27BD8-8BD6-AC9C-E951-76C9C3523B49}"/>
+          <p:cNvPr id="5" name="Imagen 4">
+            <a:extLst>
+              <a:ext uri="{FF2B5EF4-FFF2-40B4-BE49-F238E27FC236}">
+                <a16:creationId xmlns:a16="http://schemas.microsoft.com/office/drawing/2014/main" id="{1DEE1CAB-CB4B-B465-FD67-6998B00277C0}"/>
               </a:ext>
             </a:extLst>
           </p:cNvPr>
@@ -7109,8 +7109,8 @@
         </p:blipFill>
         <p:spPr>
           <a:xfrm>
-            <a:off x="1055500" y="0"/>
-            <a:ext cx="10080999" cy="6858000"/>
+            <a:off x="881006" y="0"/>
+            <a:ext cx="10429987" cy="6858000"/>
           </a:xfrm>
           <a:prstGeom prst="rect">
             <a:avLst/>
@@ -7750,21 +7750,6 @@
 </file>
 
 <file path=customXml/item1.xml><?xml version="1.0" encoding="utf-8"?>
-<p:properties xmlns:p="http://schemas.microsoft.com/office/2006/metadata/properties" xmlns:xsi="http://www.w3.org/2001/XMLSchema-instance" xmlns:pc="http://schemas.microsoft.com/office/infopath/2007/PartnerControls">
-  <documentManagement>
-    <SharedWithUsers xmlns="7b814fa0-4f1b-4d56-8a36-064af1e36e66">
-      <UserInfo>
-        <DisplayName/>
-        <AccountId xsi:nil="true"/>
-        <AccountType/>
-      </UserInfo>
-    </SharedWithUsers>
-    <_activity xmlns="b1fa7ccf-aa4f-4f27-84db-07667d020acb" xsi:nil="true"/>
-  </documentManagement>
-</p:properties>
-</file>
-
-<file path=customXml/item2.xml><?xml version="1.0" encoding="utf-8"?>
 <ct:contentTypeSchema xmlns:ct="http://schemas.microsoft.com/office/2006/metadata/contentType" xmlns:ma="http://schemas.microsoft.com/office/2006/metadata/properties/metaAttributes" ct:_="" ma:_="" ma:contentTypeName="Documento" ma:contentTypeID="0x01010063BD3DC6F0E81D4FA56575A4B7B24AF5" ma:contentTypeVersion="14" ma:contentTypeDescription="Crear nuevo documento." ma:contentTypeScope="" ma:versionID="ded3d347f3a98b31a82ee0cc093f824b">
   <xsd:schema xmlns:xsd="http://www.w3.org/2001/XMLSchema" xmlns:xs="http://www.w3.org/2001/XMLSchema" xmlns:p="http://schemas.microsoft.com/office/2006/metadata/properties" xmlns:ns3="7b814fa0-4f1b-4d56-8a36-064af1e36e66" xmlns:ns4="b1fa7ccf-aa4f-4f27-84db-07667d020acb" targetNamespace="http://schemas.microsoft.com/office/2006/metadata/properties" ma:root="true" ma:fieldsID="fe3adeea5df1e60fd0d7c7fb86895927" ns3:_="" ns4:_="">
     <xsd:import namespace="7b814fa0-4f1b-4d56-8a36-064af1e36e66"/>
@@ -7993,6 +7978,21 @@
 </ct:contentTypeSchema>
 </file>
 
+<file path=customXml/item2.xml><?xml version="1.0" encoding="utf-8"?>
+<p:properties xmlns:p="http://schemas.microsoft.com/office/2006/metadata/properties" xmlns:xsi="http://www.w3.org/2001/XMLSchema-instance" xmlns:pc="http://schemas.microsoft.com/office/infopath/2007/PartnerControls">
+  <documentManagement>
+    <SharedWithUsers xmlns="7b814fa0-4f1b-4d56-8a36-064af1e36e66">
+      <UserInfo>
+        <DisplayName/>
+        <AccountId xsi:nil="true"/>
+        <AccountType/>
+      </UserInfo>
+    </SharedWithUsers>
+    <_activity xmlns="b1fa7ccf-aa4f-4f27-84db-07667d020acb" xsi:nil="true"/>
+  </documentManagement>
+</p:properties>
+</file>
+
 <file path=customXml/item3.xml><?xml version="1.0" encoding="utf-8"?>
 <?mso-contentType ?>
 <FormTemplates xmlns="http://schemas.microsoft.com/sharepoint/v3/contenttype/forms">
@@ -8003,23 +8003,6 @@
 </file>
 
 <file path=customXml/itemProps1.xml><?xml version="1.0" encoding="utf-8"?>
-<ds:datastoreItem xmlns:ds="http://schemas.openxmlformats.org/officeDocument/2006/customXml" ds:itemID="{4FBF3923-D9E5-4962-BBB8-690B0ABC4F42}">
-  <ds:schemaRefs>
-    <ds:schemaRef ds:uri="http://www.w3.org/XML/1998/namespace"/>
-    <ds:schemaRef ds:uri="b1fa7ccf-aa4f-4f27-84db-07667d020acb"/>
-    <ds:schemaRef ds:uri="http://schemas.microsoft.com/office/2006/metadata/properties"/>
-    <ds:schemaRef ds:uri="http://schemas.microsoft.com/office/2006/documentManagement/types"/>
-    <ds:schemaRef ds:uri="http://purl.org/dc/elements/1.1/"/>
-    <ds:schemaRef ds:uri="http://schemas.microsoft.com/office/infopath/2007/PartnerControls"/>
-    <ds:schemaRef ds:uri="http://schemas.openxmlformats.org/package/2006/metadata/core-properties"/>
-    <ds:schemaRef ds:uri="7b814fa0-4f1b-4d56-8a36-064af1e36e66"/>
-    <ds:schemaRef ds:uri="http://purl.org/dc/dcmitype/"/>
-    <ds:schemaRef ds:uri="http://purl.org/dc/terms/"/>
-  </ds:schemaRefs>
-</ds:datastoreItem>
-</file>
-
-<file path=customXml/itemProps2.xml><?xml version="1.0" encoding="utf-8"?>
 <ds:datastoreItem xmlns:ds="http://schemas.openxmlformats.org/officeDocument/2006/customXml" ds:itemID="{E77A2FCE-FB77-4A2D-98B9-B8BD51BEE8CE}">
   <ds:schemaRefs>
     <ds:schemaRef ds:uri="http://schemas.microsoft.com/office/2006/metadata/contentType"/>
@@ -8038,6 +8021,23 @@
 </ds:datastoreItem>
 </file>
 
+<file path=customXml/itemProps2.xml><?xml version="1.0" encoding="utf-8"?>
+<ds:datastoreItem xmlns:ds="http://schemas.openxmlformats.org/officeDocument/2006/customXml" ds:itemID="{4FBF3923-D9E5-4962-BBB8-690B0ABC4F42}">
+  <ds:schemaRefs>
+    <ds:schemaRef ds:uri="http://www.w3.org/XML/1998/namespace"/>
+    <ds:schemaRef ds:uri="b1fa7ccf-aa4f-4f27-84db-07667d020acb"/>
+    <ds:schemaRef ds:uri="http://schemas.microsoft.com/office/2006/metadata/properties"/>
+    <ds:schemaRef ds:uri="http://schemas.microsoft.com/office/2006/documentManagement/types"/>
+    <ds:schemaRef ds:uri="http://purl.org/dc/elements/1.1/"/>
+    <ds:schemaRef ds:uri="http://schemas.microsoft.com/office/infopath/2007/PartnerControls"/>
+    <ds:schemaRef ds:uri="http://schemas.openxmlformats.org/package/2006/metadata/core-properties"/>
+    <ds:schemaRef ds:uri="7b814fa0-4f1b-4d56-8a36-064af1e36e66"/>
+    <ds:schemaRef ds:uri="http://purl.org/dc/dcmitype/"/>
+    <ds:schemaRef ds:uri="http://purl.org/dc/terms/"/>
+  </ds:schemaRefs>
+</ds:datastoreItem>
+</file>
+
 <file path=customXml/itemProps3.xml><?xml version="1.0" encoding="utf-8"?>
 <ds:datastoreItem xmlns:ds="http://schemas.openxmlformats.org/officeDocument/2006/customXml" ds:itemID="{04171512-FDE1-4E49-B7EA-58AD2B333724}">
   <ds:schemaRefs>

</xml_diff>